<commit_message>
fix: update retro crt cover art with blank phosphor screen and matte solid desk
</commit_message>
<xml_diff>
--- a/labs/36-cors-and-csrf/result/linkedin/lab-36-cors-and-csrf-carousel.pptx
+++ b/labs/36-cors-and-csrf/result/linkedin/lab-36-cors-and-csrf-carousel.pptx
@@ -6833,63 +6833,35 @@
       </p:sp>
       <p:sp>
         <p:nvSpPr>
-          <p:cNvPr id="6" name="Rounded Rectangle 5"/>
-          <p:cNvSpPr/>
-          <p:nvPr/>
-        </p:nvSpPr>
-        <p:spPr>
-          <a:xfrm>
-            <a:off x="914400" y="4389120"/>
-            <a:ext cx="10362895" cy="1645920"/>
-          </a:xfrm>
-          <a:prstGeom prst="roundRect">
-            <a:avLst/>
-          </a:prstGeom>
-          <a:solidFill>
-            <a:srgbClr val="1E293B"/>
-          </a:solidFill>
-          <a:ln>
-            <a:solidFill>
-              <a:srgbClr val="087F76"/>
-            </a:solidFill>
-          </a:ln>
-        </p:spPr>
-        <p:style>
-          <a:lnRef idx="1">
-            <a:schemeClr val="accent1"/>
-          </a:lnRef>
-          <a:fillRef idx="3">
-            <a:schemeClr val="accent1"/>
-          </a:fillRef>
-          <a:effectRef idx="2">
-            <a:schemeClr val="accent1"/>
-          </a:effectRef>
-          <a:fontRef idx="minor">
-            <a:schemeClr val="lt1"/>
-          </a:fontRef>
-        </p:style>
-        <p:txBody>
-          <a:bodyPr rtlCol="0" anchor="ctr" wrap="square"/>
-          <a:lstStyle/>
-          <a:p>
-            <a:pPr algn="ctr">
-              <a:defRPr sz="1500">
-                <a:solidFill>
-                  <a:srgbClr val="087F76"/>
-                </a:solidFill>
-                <a:latin typeface="Courier New"/>
-              </a:defRPr>
-            </a:pPr>
-            <a:r>
-              <a:t>&gt; system_check --lab 36 --topic 'cors-and-csrf'</a:t>
-            </a:r>
-            <a:br/>
-            <a:r>
-              <a:t>&gt; author: Lukman / lukman-ss | status: PRODUCTION VERIFIED</a:t>
-            </a:r>
-            <a:br/>
-            <a:r>
-              <a:t>&gt; commit: 7ced81ed | tests: PASS</a:t>
+          <p:cNvPr id="6" name="TextBox 5"/>
+          <p:cNvSpPr txBox="1"/>
+          <p:nvPr/>
+        </p:nvSpPr>
+        <p:spPr>
+          <a:xfrm>
+            <a:off x="914400" y="5303520"/>
+            <a:ext cx="5486400" cy="548640"/>
+          </a:xfrm>
+          <a:prstGeom prst="rect">
+            <a:avLst/>
+          </a:prstGeom>
+          <a:noFill/>
+        </p:spPr>
+        <p:txBody>
+          <a:bodyPr wrap="none">
+            <a:spAutoFit/>
+          </a:bodyPr>
+          <a:lstStyle/>
+          <a:p>
+            <a:pPr>
+              <a:defRPr sz="1800" b="1">
+                <a:solidFill>
+                  <a:srgbClr val="D97706"/>
+                </a:solidFill>
+              </a:defRPr>
+            </a:pPr>
+            <a:r>
+              <a:t>Lukman / lukman-ss</a:t>
             </a:r>
           </a:p>
         </p:txBody>
@@ -14554,7 +14526,11 @@
               </a:defRPr>
             </a:pPr>
             <a:r>
-              <a:t>github.com/lukman-ss/software-engineering-lab/tree/main/labs/36-cors-and-csrf</a:t>
+              <a:t>github.com/lukman-ss/software-engineering-lab</a:t>
+            </a:r>
+            <a:br/>
+            <a:r>
+              <a:t>labs/36-cors-and-csrf</a:t>
             </a:r>
           </a:p>
         </p:txBody>

</xml_diff>